<commit_message>
Actualizacion de la documentacion
</commit_message>
<xml_diff>
--- a/Doc/PresentacionProyectoFinalSolidity.pptx
+++ b/Doc/PresentacionProyectoFinalSolidity.pptx
@@ -742,7 +742,7 @@
           <a:p>
             <a:fld id="{6091C3C9-4407-446B-8271-D177C97F1B25}" type="datetimeFigureOut">
               <a:rPr lang="es-ES" smtClean="0"/>
-              <a:t>02/12/2025</a:t>
+              <a:t>03/12/2025</a:t>
             </a:fld>
             <a:endParaRPr lang="es-ES"/>
           </a:p>
@@ -921,7 +921,7 @@
           <a:p>
             <a:fld id="{6091C3C9-4407-446B-8271-D177C97F1B25}" type="datetimeFigureOut">
               <a:rPr lang="es-ES" smtClean="0"/>
-              <a:t>02/12/2025</a:t>
+              <a:t>03/12/2025</a:t>
             </a:fld>
             <a:endParaRPr lang="es-ES"/>
           </a:p>
@@ -1100,7 +1100,7 @@
           <a:p>
             <a:fld id="{6091C3C9-4407-446B-8271-D177C97F1B25}" type="datetimeFigureOut">
               <a:rPr lang="es-ES" smtClean="0"/>
-              <a:t>02/12/2025</a:t>
+              <a:t>03/12/2025</a:t>
             </a:fld>
             <a:endParaRPr lang="es-ES"/>
           </a:p>
@@ -1265,7 +1265,7 @@
           <a:p>
             <a:fld id="{6091C3C9-4407-446B-8271-D177C97F1B25}" type="datetimeFigureOut">
               <a:rPr lang="es-ES" smtClean="0"/>
-              <a:t>02/12/2025</a:t>
+              <a:t>03/12/2025</a:t>
             </a:fld>
             <a:endParaRPr lang="es-ES"/>
           </a:p>
@@ -1504,7 +1504,7 @@
           <a:p>
             <a:fld id="{6091C3C9-4407-446B-8271-D177C97F1B25}" type="datetimeFigureOut">
               <a:rPr lang="es-ES" smtClean="0"/>
-              <a:t>02/12/2025</a:t>
+              <a:t>03/12/2025</a:t>
             </a:fld>
             <a:endParaRPr lang="es-ES"/>
           </a:p>
@@ -1617,7 +1617,7 @@
           <a:p>
             <a:fld id="{6091C3C9-4407-446B-8271-D177C97F1B25}" type="datetimeFigureOut">
               <a:rPr lang="es-ES" smtClean="0"/>
-              <a:t>02/12/2025</a:t>
+              <a:t>03/12/2025</a:t>
             </a:fld>
             <a:endParaRPr lang="es-ES"/>
           </a:p>
@@ -1990,7 +1990,7 @@
           <a:p>
             <a:fld id="{6091C3C9-4407-446B-8271-D177C97F1B25}" type="datetimeFigureOut">
               <a:rPr lang="es-ES" smtClean="0"/>
-              <a:t>02/12/2025</a:t>
+              <a:t>03/12/2025</a:t>
             </a:fld>
             <a:endParaRPr lang="es-ES"/>
           </a:p>
@@ -2217,7 +2217,7 @@
           <a:p>
             <a:fld id="{6091C3C9-4407-446B-8271-D177C97F1B25}" type="datetimeFigureOut">
               <a:rPr lang="es-ES" smtClean="0"/>
-              <a:t>02/12/2025</a:t>
+              <a:t>03/12/2025</a:t>
             </a:fld>
             <a:endParaRPr lang="es-ES"/>
           </a:p>
@@ -2307,7 +2307,7 @@
           <a:p>
             <a:fld id="{6091C3C9-4407-446B-8271-D177C97F1B25}" type="datetimeFigureOut">
               <a:rPr lang="es-ES" smtClean="0"/>
-              <a:t>02/12/2025</a:t>
+              <a:t>03/12/2025</a:t>
             </a:fld>
             <a:endParaRPr lang="es-ES"/>
           </a:p>
@@ -3134,7 +3134,7 @@
           <a:p>
             <a:fld id="{6091C3C9-4407-446B-8271-D177C97F1B25}" type="datetimeFigureOut">
               <a:rPr lang="es-ES" smtClean="0"/>
-              <a:t>02/12/2025</a:t>
+              <a:t>03/12/2025</a:t>
             </a:fld>
             <a:endParaRPr lang="es-ES"/>
           </a:p>
@@ -3965,7 +3965,7 @@
           <a:p>
             <a:fld id="{6091C3C9-4407-446B-8271-D177C97F1B25}" type="datetimeFigureOut">
               <a:rPr lang="es-ES" smtClean="0"/>
-              <a:t>02/12/2025</a:t>
+              <a:t>03/12/2025</a:t>
             </a:fld>
             <a:endParaRPr lang="es-ES"/>
           </a:p>
@@ -4619,7 +4619,7 @@
           <a:p>
             <a:fld id="{6091C3C9-4407-446B-8271-D177C97F1B25}" type="datetimeFigureOut">
               <a:rPr lang="es-ES" smtClean="0"/>
-              <a:t>02/12/2025</a:t>
+              <a:t>03/12/2025</a:t>
             </a:fld>
             <a:endParaRPr lang="es-ES"/>
           </a:p>
@@ -5237,7 +5237,7 @@
           <a:p>
             <a:r>
               <a:rPr lang="es-ES" sz="2800" dirty="0" smtClean="0"/>
-              <a:t>- [02_PROYECTO_IMPLEMENTADO_Y_ANALISIS.md]</a:t>
+              <a:t>-[02_PROYECTO_IMPLEMENTADO_Y_ANALISIS.md]</a:t>
             </a:r>
           </a:p>
           <a:p>
@@ -5255,7 +5255,7 @@
           <a:p>
             <a:r>
               <a:rPr lang="es-ES" sz="2800" dirty="0" smtClean="0"/>
-              <a:t>- [05_IA.m]</a:t>
+              <a:t>- [05_IA.md]</a:t>
             </a:r>
             <a:endParaRPr lang="es-ES" sz="2800" dirty="0"/>
           </a:p>

</xml_diff>